<commit_message>
Added minor changes to W1-4 lecture notes, adding instructor bios
</commit_message>
<xml_diff>
--- a/W1/2. W1S2 final/W1S2.pptx
+++ b/W1/2. W1S2 final/W1S2.pptx
@@ -241,7 +241,7 @@
 <file path=ppt/revisionInfo.xml><?xml version="1.0" encoding="utf-8"?>
 <p1510:revInfo xmlns:a="http://schemas.openxmlformats.org/drawingml/2006/main" xmlns:r="http://schemas.openxmlformats.org/officeDocument/2006/relationships" xmlns:p1510="http://schemas.microsoft.com/office/powerpoint/2015/10/main">
   <p1510:revLst>
-    <p1510:client id="{D969CBA9-08F9-448D-A83C-3503CC0AD359}" v="39" dt="2025-12-18T21:22:09.969"/>
+    <p1510:client id="{2C083308-696B-45F0-8323-061DEF55DE8A}" v="1" dt="2026-01-16T05:10:18.491"/>
   </p1510:revLst>
 </p1510:revInfo>
 </file>
@@ -251,7 +251,7 @@
   <pc:docChgLst>
     <pc:chgData name="Matthieu De Mari" userId="dfb708c9-d8dc-439f-9a3b-c772bf4a311c" providerId="ADAL" clId="{81E9B007-0C2C-493E-9B93-55A62C9C1F12}"/>
     <pc:docChg chg="undo custSel addSld delSld modSld modSection">
-      <pc:chgData name="Matthieu De Mari" userId="dfb708c9-d8dc-439f-9a3b-c772bf4a311c" providerId="ADAL" clId="{81E9B007-0C2C-493E-9B93-55A62C9C1F12}" dt="2025-12-18T21:22:34.717" v="397" actId="20577"/>
+      <pc:chgData name="Matthieu De Mari" userId="dfb708c9-d8dc-439f-9a3b-c772bf4a311c" providerId="ADAL" clId="{81E9B007-0C2C-493E-9B93-55A62C9C1F12}" dt="2026-01-16T05:11:06.280" v="546" actId="20577"/>
       <pc:docMkLst>
         <pc:docMk/>
       </pc:docMkLst>
@@ -435,59 +435,20 @@
           </ac:spMkLst>
         </pc:spChg>
       </pc:sldChg>
-      <pc:sldChg chg="add">
-        <pc:chgData name="Matthieu De Mari" userId="dfb708c9-d8dc-439f-9a3b-c772bf4a311c" providerId="ADAL" clId="{81E9B007-0C2C-493E-9B93-55A62C9C1F12}" dt="2025-12-18T21:15:01.636" v="263"/>
+      <pc:sldChg chg="addSp modSp add mod">
+        <pc:chgData name="Matthieu De Mari" userId="dfb708c9-d8dc-439f-9a3b-c772bf4a311c" providerId="ADAL" clId="{81E9B007-0C2C-493E-9B93-55A62C9C1F12}" dt="2026-01-16T05:11:06.280" v="546" actId="20577"/>
         <pc:sldMkLst>
           <pc:docMk/>
           <pc:sldMk cId="1061347991" sldId="539"/>
         </pc:sldMkLst>
-      </pc:sldChg>
-      <pc:sldChg chg="addSp delSp modSp add del mod">
-        <pc:chgData name="Matthieu De Mari" userId="dfb708c9-d8dc-439f-9a3b-c772bf4a311c" providerId="ADAL" clId="{81E9B007-0C2C-493E-9B93-55A62C9C1F12}" dt="2025-12-18T21:14:46.458" v="262" actId="2696"/>
-        <pc:sldMkLst>
-          <pc:docMk/>
-          <pc:sldMk cId="3438076525" sldId="539"/>
-        </pc:sldMkLst>
-        <pc:spChg chg="del">
-          <ac:chgData name="Matthieu De Mari" userId="dfb708c9-d8dc-439f-9a3b-c772bf4a311c" providerId="ADAL" clId="{81E9B007-0C2C-493E-9B93-55A62C9C1F12}" dt="2025-12-18T21:11:05.689" v="6" actId="478"/>
+        <pc:spChg chg="add mod">
+          <ac:chgData name="Matthieu De Mari" userId="dfb708c9-d8dc-439f-9a3b-c772bf4a311c" providerId="ADAL" clId="{81E9B007-0C2C-493E-9B93-55A62C9C1F12}" dt="2026-01-16T05:11:06.280" v="546" actId="20577"/>
           <ac:spMkLst>
             <pc:docMk/>
-            <pc:sldMk cId="3438076525" sldId="539"/>
-            <ac:spMk id="2" creationId="{B69DE8EC-303C-D2DC-6681-0F9721FB24E1}"/>
+            <pc:sldMk cId="1061347991" sldId="539"/>
+            <ac:spMk id="2" creationId="{CBFC0A27-8316-F94E-FB36-D8BC6E05AB71}"/>
           </ac:spMkLst>
         </pc:spChg>
-        <pc:spChg chg="del">
-          <ac:chgData name="Matthieu De Mari" userId="dfb708c9-d8dc-439f-9a3b-c772bf4a311c" providerId="ADAL" clId="{81E9B007-0C2C-493E-9B93-55A62C9C1F12}" dt="2025-12-18T21:10:46.437" v="1" actId="478"/>
-          <ac:spMkLst>
-            <pc:docMk/>
-            <pc:sldMk cId="3438076525" sldId="539"/>
-            <ac:spMk id="4" creationId="{3FEBB3A6-470C-C5E3-3A02-8845AD25C349}"/>
-          </ac:spMkLst>
-        </pc:spChg>
-        <pc:spChg chg="mod">
-          <ac:chgData name="Matthieu De Mari" userId="dfb708c9-d8dc-439f-9a3b-c772bf4a311c" providerId="ADAL" clId="{81E9B007-0C2C-493E-9B93-55A62C9C1F12}" dt="2025-12-18T21:14:28.651" v="261" actId="20577"/>
-          <ac:spMkLst>
-            <pc:docMk/>
-            <pc:sldMk cId="3438076525" sldId="539"/>
-            <ac:spMk id="5" creationId="{6AE76912-3D36-2FB5-A4F8-1BEAEE6224C7}"/>
-          </ac:spMkLst>
-        </pc:spChg>
-        <pc:picChg chg="del">
-          <ac:chgData name="Matthieu De Mari" userId="dfb708c9-d8dc-439f-9a3b-c772bf4a311c" providerId="ADAL" clId="{81E9B007-0C2C-493E-9B93-55A62C9C1F12}" dt="2025-12-18T21:11:00.809" v="4" actId="478"/>
-          <ac:picMkLst>
-            <pc:docMk/>
-            <pc:sldMk cId="3438076525" sldId="539"/>
-            <ac:picMk id="3" creationId="{9D3A730F-3828-A114-A486-B42BEFB2A6F2}"/>
-          </ac:picMkLst>
-        </pc:picChg>
-        <pc:picChg chg="add mod modCrop">
-          <ac:chgData name="Matthieu De Mari" userId="dfb708c9-d8dc-439f-9a3b-c772bf4a311c" providerId="ADAL" clId="{81E9B007-0C2C-493E-9B93-55A62C9C1F12}" dt="2025-12-18T21:12:25.281" v="23" actId="1076"/>
-          <ac:picMkLst>
-            <pc:docMk/>
-            <pc:sldMk cId="3438076525" sldId="539"/>
-            <ac:picMk id="7" creationId="{F5C7337F-2AD3-3D35-E695-83C54AE5131A}"/>
-          </ac:picMkLst>
-        </pc:picChg>
       </pc:sldChg>
     </pc:docChg>
   </pc:docChgLst>
@@ -576,7 +537,7 @@
           <a:p>
             <a:fld id="{61478373-EB31-4867-8CF0-FA31364748A5}" type="datetimeFigureOut">
               <a:rPr lang="en-GB" smtClean="0"/>
-              <a:t>18/12/2025</a:t>
+              <a:t>16/01/2026</a:t>
             </a:fld>
             <a:endParaRPr lang="en-GB"/>
           </a:p>
@@ -993,7 +954,7 @@
           <a:p>
             <a:fld id="{E85DF616-B21E-4EF6-A6A5-95E2FB3EB1A1}" type="datetimeFigureOut">
               <a:rPr lang="en-GB" smtClean="0"/>
-              <a:t>18/12/2025</a:t>
+              <a:t>16/01/2026</a:t>
             </a:fld>
             <a:endParaRPr lang="en-GB"/>
           </a:p>
@@ -1193,7 +1154,7 @@
           <a:p>
             <a:fld id="{E85DF616-B21E-4EF6-A6A5-95E2FB3EB1A1}" type="datetimeFigureOut">
               <a:rPr lang="en-GB" smtClean="0"/>
-              <a:t>18/12/2025</a:t>
+              <a:t>16/01/2026</a:t>
             </a:fld>
             <a:endParaRPr lang="en-GB"/>
           </a:p>
@@ -1403,7 +1364,7 @@
           <a:p>
             <a:fld id="{E85DF616-B21E-4EF6-A6A5-95E2FB3EB1A1}" type="datetimeFigureOut">
               <a:rPr lang="en-GB" smtClean="0"/>
-              <a:t>18/12/2025</a:t>
+              <a:t>16/01/2026</a:t>
             </a:fld>
             <a:endParaRPr lang="en-GB"/>
           </a:p>
@@ -1603,7 +1564,7 @@
           <a:p>
             <a:fld id="{E85DF616-B21E-4EF6-A6A5-95E2FB3EB1A1}" type="datetimeFigureOut">
               <a:rPr lang="en-GB" smtClean="0"/>
-              <a:t>18/12/2025</a:t>
+              <a:t>16/01/2026</a:t>
             </a:fld>
             <a:endParaRPr lang="en-GB"/>
           </a:p>
@@ -1879,7 +1840,7 @@
           <a:p>
             <a:fld id="{E85DF616-B21E-4EF6-A6A5-95E2FB3EB1A1}" type="datetimeFigureOut">
               <a:rPr lang="en-GB" smtClean="0"/>
-              <a:t>18/12/2025</a:t>
+              <a:t>16/01/2026</a:t>
             </a:fld>
             <a:endParaRPr lang="en-GB"/>
           </a:p>
@@ -2147,7 +2108,7 @@
           <a:p>
             <a:fld id="{E85DF616-B21E-4EF6-A6A5-95E2FB3EB1A1}" type="datetimeFigureOut">
               <a:rPr lang="en-GB" smtClean="0"/>
-              <a:t>18/12/2025</a:t>
+              <a:t>16/01/2026</a:t>
             </a:fld>
             <a:endParaRPr lang="en-GB"/>
           </a:p>
@@ -2562,7 +2523,7 @@
           <a:p>
             <a:fld id="{E85DF616-B21E-4EF6-A6A5-95E2FB3EB1A1}" type="datetimeFigureOut">
               <a:rPr lang="en-GB" smtClean="0"/>
-              <a:t>18/12/2025</a:t>
+              <a:t>16/01/2026</a:t>
             </a:fld>
             <a:endParaRPr lang="en-GB"/>
           </a:p>
@@ -2704,7 +2665,7 @@
           <a:p>
             <a:fld id="{E85DF616-B21E-4EF6-A6A5-95E2FB3EB1A1}" type="datetimeFigureOut">
               <a:rPr lang="en-GB" smtClean="0"/>
-              <a:t>18/12/2025</a:t>
+              <a:t>16/01/2026</a:t>
             </a:fld>
             <a:endParaRPr lang="en-GB"/>
           </a:p>
@@ -2817,7 +2778,7 @@
           <a:p>
             <a:fld id="{E85DF616-B21E-4EF6-A6A5-95E2FB3EB1A1}" type="datetimeFigureOut">
               <a:rPr lang="en-GB" smtClean="0"/>
-              <a:t>18/12/2025</a:t>
+              <a:t>16/01/2026</a:t>
             </a:fld>
             <a:endParaRPr lang="en-GB"/>
           </a:p>
@@ -3130,7 +3091,7 @@
           <a:p>
             <a:fld id="{E85DF616-B21E-4EF6-A6A5-95E2FB3EB1A1}" type="datetimeFigureOut">
               <a:rPr lang="en-GB" smtClean="0"/>
-              <a:t>18/12/2025</a:t>
+              <a:t>16/01/2026</a:t>
             </a:fld>
             <a:endParaRPr lang="en-GB"/>
           </a:p>
@@ -3419,7 +3380,7 @@
           <a:p>
             <a:fld id="{E85DF616-B21E-4EF6-A6A5-95E2FB3EB1A1}" type="datetimeFigureOut">
               <a:rPr lang="en-GB" smtClean="0"/>
-              <a:t>18/12/2025</a:t>
+              <a:t>16/01/2026</a:t>
             </a:fld>
             <a:endParaRPr lang="en-GB"/>
           </a:p>
@@ -3662,7 +3623,7 @@
           <a:p>
             <a:fld id="{E85DF616-B21E-4EF6-A6A5-95E2FB3EB1A1}" type="datetimeFigureOut">
               <a:rPr lang="en-GB" smtClean="0"/>
-              <a:t>18/12/2025</a:t>
+              <a:t>16/01/2026</a:t>
             </a:fld>
             <a:endParaRPr lang="en-GB"/>
           </a:p>
@@ -7608,6 +7569,45 @@
           </a:prstGeom>
         </p:spPr>
       </p:pic>
+      <p:sp>
+        <p:nvSpPr>
+          <p:cNvPr id="2" name="TextBox 1">
+            <a:extLst>
+              <a:ext uri="{FF2B5EF4-FFF2-40B4-BE49-F238E27FC236}">
+                <a16:creationId xmlns:a16="http://schemas.microsoft.com/office/drawing/2014/main" id="{CBFC0A27-8316-F94E-FB36-D8BC6E05AB71}"/>
+              </a:ext>
+            </a:extLst>
+          </p:cNvPr>
+          <p:cNvSpPr txBox="1"/>
+          <p:nvPr/>
+        </p:nvSpPr>
+        <p:spPr>
+          <a:xfrm>
+            <a:off x="4496499" y="6116069"/>
+            <a:ext cx="7298422" cy="646331"/>
+          </a:xfrm>
+          <a:prstGeom prst="rect">
+            <a:avLst/>
+          </a:prstGeom>
+          <a:noFill/>
+        </p:spPr>
+        <p:txBody>
+          <a:bodyPr wrap="square" rtlCol="0">
+            <a:spAutoFit/>
+          </a:bodyPr>
+          <a:lstStyle/>
+          <a:p>
+            <a:r>
+              <a:rPr lang="en-GB" b="1" dirty="0">
+                <a:solidFill>
+                  <a:schemeClr val="accent2"/>
+                </a:solidFill>
+              </a:rPr>
+              <a:t>Note: This overfitting (above) was observed on a Neural Network model, not a polynomial regression, but the observation still holds.</a:t>
+            </a:r>
+          </a:p>
+        </p:txBody>
+      </p:sp>
     </p:spTree>
     <p:extLst>
       <p:ext uri="{BB962C8B-B14F-4D97-AF65-F5344CB8AC3E}">
@@ -10430,8 +10430,8 @@
           </a:p>
         </p:txBody>
       </p:sp>
-      <mc:AlternateContent xmlns:mc="http://schemas.openxmlformats.org/markup-compatibility/2006">
-        <mc:Choice xmlns:a14="http://schemas.microsoft.com/office/drawing/2010/main" Requires="a14">
+      <mc:AlternateContent xmlns:mc="http://schemas.openxmlformats.org/markup-compatibility/2006" xmlns:a14="http://schemas.microsoft.com/office/drawing/2010/main">
+        <mc:Choice Requires="a14">
           <p:sp>
             <p:nvSpPr>
               <p:cNvPr id="3" name="Content Placeholder 2">
@@ -10600,7 +10600,7 @@
             </p:txBody>
           </p:sp>
         </mc:Choice>
-        <mc:Fallback>
+        <mc:Fallback xmlns="">
           <p:sp>
             <p:nvSpPr>
               <p:cNvPr id="3" name="Content Placeholder 2">
@@ -11122,8 +11122,8 @@
           </a:p>
         </p:txBody>
       </p:sp>
-      <mc:AlternateContent xmlns:mc="http://schemas.openxmlformats.org/markup-compatibility/2006">
-        <mc:Choice xmlns:a14="http://schemas.microsoft.com/office/drawing/2010/main" Requires="a14">
+      <mc:AlternateContent xmlns:mc="http://schemas.openxmlformats.org/markup-compatibility/2006" xmlns:a14="http://schemas.microsoft.com/office/drawing/2010/main">
+        <mc:Choice Requires="a14">
           <p:sp>
             <p:nvSpPr>
               <p:cNvPr id="4" name="Content Placeholder 3">
@@ -11222,7 +11222,7 @@
             </p:txBody>
           </p:sp>
         </mc:Choice>
-        <mc:Fallback>
+        <mc:Fallback xmlns="">
           <p:sp>
             <p:nvSpPr>
               <p:cNvPr id="4" name="Content Placeholder 3">
@@ -12406,8 +12406,8 @@
           </p:sp>
         </mc:Fallback>
       </mc:AlternateContent>
-      <mc:AlternateContent xmlns:mc="http://schemas.openxmlformats.org/markup-compatibility/2006">
-        <mc:Choice xmlns:a14="http://schemas.microsoft.com/office/drawing/2010/main" Requires="a14">
+      <mc:AlternateContent xmlns:mc="http://schemas.openxmlformats.org/markup-compatibility/2006" xmlns:a14="http://schemas.microsoft.com/office/drawing/2010/main">
+        <mc:Choice Requires="a14">
           <p:sp>
             <p:nvSpPr>
               <p:cNvPr id="7" name="Content Placeholder 2">
@@ -12590,7 +12590,7 @@
             </p:txBody>
           </p:sp>
         </mc:Choice>
-        <mc:Fallback>
+        <mc:Fallback xmlns="">
           <p:sp>
             <p:nvSpPr>
               <p:cNvPr id="7" name="Content Placeholder 2">
@@ -12754,8 +12754,8 @@
           </a:prstGeom>
         </p:spPr>
       </p:pic>
-      <mc:AlternateContent xmlns:mc="http://schemas.openxmlformats.org/markup-compatibility/2006">
-        <mc:Choice xmlns:a14="http://schemas.microsoft.com/office/drawing/2010/main" Requires="a14">
+      <mc:AlternateContent xmlns:mc="http://schemas.openxmlformats.org/markup-compatibility/2006" xmlns:a14="http://schemas.microsoft.com/office/drawing/2010/main">
+        <mc:Choice Requires="a14">
           <p:sp>
             <p:nvSpPr>
               <p:cNvPr id="2" name="TextBox 1">
@@ -12879,7 +12879,7 @@
             </p:txBody>
           </p:sp>
         </mc:Choice>
-        <mc:Fallback>
+        <mc:Fallback xmlns="">
           <p:sp>
             <p:nvSpPr>
               <p:cNvPr id="2" name="TextBox 1">

</xml_diff>